<commit_message>
feat: add Mobile Application and Emergency Corridor to Future Scope in PPTX, HTML, and README
</commit_message>
<xml_diff>
--- a/ppt/AI_Traffic_Management_Presentation.pptx
+++ b/ppt/AI_Traffic_Management_Presentation.pptx
@@ -5240,67 +5240,82 @@
               </a:defRPr>
             </a:pPr>
             <a:r>
-              <a:t>•  1. Real-Time IoT Sensor Integration: Ingest live ultrasonic and inductive loop traffic sensors.</a:t>
-            </a:r>
-          </a:p>
-          <a:p>
-            <a:pPr>
-              <a:spcAft>
-                <a:spcPts val="500"/>
-              </a:spcAft>
-              <a:defRPr sz="1300">
-                <a:solidFill>
-                  <a:srgbClr val="94A3B8"/>
-                </a:solidFill>
-              </a:defRPr>
-            </a:pPr>
-            <a:r>
-              <a:t>•  2. GPS &amp; GIS Mapping: Integrate Mapbox / OpenStreetMap with live geolocation polyline routes.</a:t>
-            </a:r>
-          </a:p>
-          <a:p>
-            <a:pPr>
-              <a:spcAft>
-                <a:spcPts val="500"/>
-              </a:spcAft>
-              <a:defRPr sz="1300">
-                <a:solidFill>
-                  <a:srgbClr val="94A3B8"/>
-                </a:solidFill>
-              </a:defRPr>
-            </a:pPr>
-            <a:r>
-              <a:t>•  3. Deep Learning Upgrade: Deploy YOLOv8 for multi-class vehicle detection on camera streams.</a:t>
-            </a:r>
-          </a:p>
-          <a:p>
-            <a:pPr>
-              <a:spcAft>
-                <a:spcPts val="500"/>
-              </a:spcAft>
-              <a:defRPr sz="1300">
-                <a:solidFill>
-                  <a:srgbClr val="94A3B8"/>
-                </a:solidFill>
-              </a:defRPr>
-            </a:pPr>
-            <a:r>
-              <a:t>•  4. Smart Traffic Signal Automation: Dynamic signal timer adjustment based on queue length.</a:t>
-            </a:r>
-          </a:p>
-          <a:p>
-            <a:pPr>
-              <a:spcAft>
-                <a:spcPts val="500"/>
-              </a:spcAft>
-              <a:defRPr sz="1300">
-                <a:solidFill>
-                  <a:srgbClr val="94A3B8"/>
-                </a:solidFill>
-              </a:defRPr>
-            </a:pPr>
-            <a:r>
-              <a:t>•  5. Cloud Deployment: Deploy on AWS EC2 / Render with automated CI/CD pipelines.</a:t>
+              <a:t>•  1. Commuter Mobile App: Cross-platform Flutter / React Native app for live turn-by-turn navigation &amp; jam alerts.</a:t>
+            </a:r>
+          </a:p>
+          <a:p>
+            <a:pPr>
+              <a:spcAft>
+                <a:spcPts val="500"/>
+              </a:spcAft>
+              <a:defRPr sz="1300">
+                <a:solidFill>
+                  <a:srgbClr val="94A3B8"/>
+                </a:solidFill>
+              </a:defRPr>
+            </a:pPr>
+            <a:r>
+              <a:t>•  2. Real-Time IoT Sensors: Ingest ultrasonic &amp; inductive loop detectors via WebSockets.</a:t>
+            </a:r>
+          </a:p>
+          <a:p>
+            <a:pPr>
+              <a:spcAft>
+                <a:spcPts val="500"/>
+              </a:spcAft>
+              <a:defRPr sz="1300">
+                <a:solidFill>
+                  <a:srgbClr val="94A3B8"/>
+                </a:solidFill>
+              </a:defRPr>
+            </a:pPr>
+            <a:r>
+              <a:t>•  3. Live GIS Maps: Integrate Mapbox / OpenStreetMap with real-time GPS routing.</a:t>
+            </a:r>
+          </a:p>
+          <a:p>
+            <a:pPr>
+              <a:spcAft>
+                <a:spcPts val="500"/>
+              </a:spcAft>
+              <a:defRPr sz="1300">
+                <a:solidFill>
+                  <a:srgbClr val="94A3B8"/>
+                </a:solidFill>
+              </a:defRPr>
+            </a:pPr>
+            <a:r>
+              <a:t>•  4. Deep Learning Vision: Deploy YOLOv8 on CCTV streams for multi-class vehicle tracking.</a:t>
+            </a:r>
+          </a:p>
+          <a:p>
+            <a:pPr>
+              <a:spcAft>
+                <a:spcPts val="500"/>
+              </a:spcAft>
+              <a:defRPr sz="1300">
+                <a:solidFill>
+                  <a:srgbClr val="94A3B8"/>
+                </a:solidFill>
+              </a:defRPr>
+            </a:pPr>
+            <a:r>
+              <a:t>•  5. Adaptive Signal Control: Automated dynamic signal timing based on congestion density.</a:t>
+            </a:r>
+          </a:p>
+          <a:p>
+            <a:pPr>
+              <a:spcAft>
+                <a:spcPts val="500"/>
+              </a:spcAft>
+              <a:defRPr sz="1300">
+                <a:solidFill>
+                  <a:srgbClr val="94A3B8"/>
+                </a:solidFill>
+              </a:defRPr>
+            </a:pPr>
+            <a:r>
+              <a:t>•  6. Emergency Green Corridor: Automated lane clearance for ambulances &amp; fire brigades.</a:t>
             </a:r>
           </a:p>
         </p:txBody>

</xml_diff>